<commit_message>
Rework cloud map per 6.28 spec: Kriging, probe config, enlarged pipe
- Replace scipy griddata with a hand-written ordinary Kriging interpolator
  (_kriging_1d, Gaussian variogram, no new dependency)
- Column-constant cloud: each probe temperature fills its whole vertical
  column, Kriging-interpolated along the pipe length between probes
- Rename the application to 高温火驱原油着火热动力学特征评价系统
- Put the 7 temperature probes in a single middle row; keep a single
  pipe-wall temperature (drop T9)
- Reproduce the slide-6 device (pipe body, flanges, nozzles, P1/P2, two
  thick solid connector lines) and enlarge it to fill the cloud area;
  remove the pipe-wall box from the cloud area
- Add a probe-config panel: per-probe Modbus channel mapping and on/off;
  a disabled temperature probe is filled in by Kriging
</commit_message>
<xml_diff>
--- a/interface.pptx
+++ b/interface.pptx
@@ -117,7 +117,7 @@
             <a:srgbClr val="A4A3A4"/>
           </p15:clr>
         </p15:guide>
-        <p15:guide id="2" pos="3864" userDrawn="1">
+        <p15:guide id="2" pos="3901" userDrawn="1">
           <p15:clr>
             <a:srgbClr val="A4A3A4"/>
           </p15:clr>
@@ -5997,40 +5997,828 @@
       <p:grpSpPr/>
       <p:sp>
         <p:nvSpPr>
-          <p:cNvPr id="2" name="标题 1"/>
-          <p:cNvSpPr>
-            <a:spLocks noGrp="1"/>
-          </p:cNvSpPr>
-          <p:nvPr>
-            <p:ph type="title"/>
-          </p:nvPr>
-        </p:nvSpPr>
-        <p:spPr/>
-        <p:txBody>
-          <a:bodyPr/>
-          <a:p>
-            <a:endParaRPr lang="zh-CN" altLang="en-US"/>
-          </a:p>
-        </p:txBody>
-      </p:sp>
-      <p:sp>
-        <p:nvSpPr>
-          <p:cNvPr id="3" name="内容占位符 2"/>
-          <p:cNvSpPr>
-            <a:spLocks noGrp="1"/>
-          </p:cNvSpPr>
-          <p:nvPr>
-            <p:ph idx="1"/>
-          </p:nvPr>
-        </p:nvSpPr>
-        <p:spPr/>
-        <p:txBody>
-          <a:bodyPr/>
-          <a:p>
-            <a:endParaRPr lang="zh-CN" altLang="en-US"/>
-          </a:p>
-        </p:txBody>
-      </p:sp>
+          <p:cNvPr id="4" name="文本框 3"/>
+          <p:cNvSpPr txBox="1"/>
+          <p:nvPr/>
+        </p:nvSpPr>
+        <p:spPr>
+          <a:xfrm>
+            <a:off x="153670" y="59690"/>
+            <a:ext cx="4064000" cy="368300"/>
+          </a:xfrm>
+          <a:prstGeom prst="rect">
+            <a:avLst/>
+          </a:prstGeom>
+          <a:noFill/>
+        </p:spPr>
+        <p:txBody>
+          <a:bodyPr wrap="square" rtlCol="0">
+            <a:spAutoFit/>
+          </a:bodyPr>
+          <a:p>
+            <a:r>
+              <a:rPr lang="en-US" altLang="zh-CN"/>
+              <a:t>6.28</a:t>
+            </a:r>
+            <a:r>
+              <a:rPr lang="zh-CN" altLang="en-US"/>
+              <a:t>修改</a:t>
+            </a:r>
+            <a:endParaRPr lang="zh-CN" altLang="en-US"/>
+          </a:p>
+        </p:txBody>
+      </p:sp>
+      <p:sp>
+        <p:nvSpPr>
+          <p:cNvPr id="5" name="文本框 4"/>
+          <p:cNvSpPr txBox="1"/>
+          <p:nvPr/>
+        </p:nvSpPr>
+        <p:spPr>
+          <a:xfrm>
+            <a:off x="227330" y="553085"/>
+            <a:ext cx="10712450" cy="3272155"/>
+          </a:xfrm>
+          <a:prstGeom prst="rect">
+            <a:avLst/>
+          </a:prstGeom>
+        </p:spPr>
+        <p:txBody>
+          <a:bodyPr>
+            <a:noAutofit/>
+          </a:bodyPr>
+          <a:p>
+            <a:pPr marL="0" indent="0" algn="l"/>
+            <a:r>
+              <a:rPr lang="zh-CN" altLang="en-US" sz="1800" b="0" i="0"/>
+              <a:t>1.确认温度插值</a:t>
+            </a:r>
+            <a:r>
+              <a:rPr lang="zh-CN" altLang="en-US" sz="1800" b="0" i="0"/>
+              <a:t>方法法用克里</a:t>
+            </a:r>
+            <a:r>
+              <a:rPr lang="zh-CN" altLang="en-US" sz="1800" b="0" i="0"/>
+              <a:t>金插值法。</a:t>
+            </a:r>
+            <a:endParaRPr lang="zh-CN" altLang="en-US" sz="1800" b="0" i="0"/>
+          </a:p>
+          <a:p>
+            <a:pPr marL="0" indent="0" algn="l"/>
+            <a:r>
+              <a:rPr lang="zh-CN" altLang="en-US" sz="1800" b="0" i="0"/>
+              <a:t>2.标题名称改成：高温火驱原油着火热动力学特征评价系统</a:t>
+            </a:r>
+            <a:endParaRPr lang="zh-CN" altLang="en-US" sz="1800" b="0" i="0"/>
+          </a:p>
+          <a:p>
+            <a:pPr marL="0" indent="0" algn="l"/>
+            <a:r>
+              <a:rPr lang="zh-CN" altLang="en-US" sz="1800" b="0" i="0"/>
+              <a:t>3.云图区整个图片放大，铺满整个云图区，越大</a:t>
+            </a:r>
+            <a:r>
+              <a:rPr lang="zh-CN" altLang="en-US" sz="1800" b="0" i="0"/>
+              <a:t>越好而且不需要有覆盖的地方,去掉多余部分，然后入口，出口加一根粗实线如下</a:t>
+            </a:r>
+            <a:r>
+              <a:rPr lang="zh-CN" altLang="en-US" sz="1800" b="0" i="0"/>
+              <a:t>图：</a:t>
+            </a:r>
+            <a:endParaRPr lang="zh-CN" altLang="en-US" sz="1800" b="0" i="0"/>
+          </a:p>
+          <a:p>
+            <a:pPr marL="0" indent="0" algn="l"/>
+            <a:endParaRPr lang="zh-CN" altLang="en-US" sz="1800" b="0" i="0"/>
+          </a:p>
+          <a:p>
+            <a:pPr marL="0" indent="0" algn="l"/>
+            <a:endParaRPr lang="zh-CN" altLang="en-US" sz="1800" b="0" i="0"/>
+          </a:p>
+          <a:p>
+            <a:pPr marL="0" indent="0" algn="l"/>
+            <a:endParaRPr lang="zh-CN" altLang="en-US" sz="1800" b="0" i="0"/>
+          </a:p>
+          <a:p>
+            <a:pPr marL="0" indent="0" algn="l"/>
+            <a:endParaRPr lang="zh-CN" altLang="en-US" sz="1800" b="0" i="0"/>
+          </a:p>
+          <a:p>
+            <a:pPr marL="0" indent="0" algn="l"/>
+            <a:endParaRPr lang="zh-CN" altLang="en-US" sz="1800" b="0" i="0"/>
+          </a:p>
+          <a:p>
+            <a:pPr marL="0" indent="0" algn="l"/>
+            <a:endParaRPr lang="zh-CN" altLang="en-US" sz="1800" b="0" i="0"/>
+          </a:p>
+          <a:p>
+            <a:pPr marL="0" indent="0" algn="l"/>
+            <a:endParaRPr lang="zh-CN" altLang="en-US" sz="1800" b="0" i="0"/>
+          </a:p>
+          <a:p>
+            <a:pPr marL="0" indent="0" algn="l"/>
+            <a:endParaRPr lang="zh-CN" altLang="en-US" sz="1800" b="0" i="0"/>
+          </a:p>
+          <a:p>
+            <a:pPr marL="0" indent="0" algn="l"/>
+            <a:endParaRPr lang="zh-CN" altLang="en-US" sz="1800" b="0" i="0"/>
+          </a:p>
+          <a:p>
+            <a:pPr marL="0" indent="0" algn="l"/>
+            <a:r>
+              <a:rPr lang="zh-CN" altLang="en-US" sz="1800" b="0" i="0"/>
+              <a:t>4.传感器放在中间，而且那一列都是用同一个温度，而不是只有那一个区域用这个温度，然后只要一个管壁温度就行，温度显示类似下面这种效果</a:t>
+            </a:r>
+            <a:r>
+              <a:rPr lang="zh-CN" altLang="en-US" sz="1800" b="0" i="0"/>
+              <a:t>就行</a:t>
+            </a:r>
+            <a:endParaRPr lang="zh-CN" altLang="en-US" sz="1800" b="0" i="0"/>
+          </a:p>
+          <a:p>
+            <a:pPr marL="0" indent="0" algn="l"/>
+            <a:endParaRPr lang="zh-CN" altLang="en-US" sz="1800" b="0" i="0"/>
+          </a:p>
+          <a:p>
+            <a:pPr marL="0" indent="0" algn="l"/>
+            <a:endParaRPr lang="zh-CN" altLang="en-US" sz="1800" b="0" i="0"/>
+          </a:p>
+          <a:p>
+            <a:pPr marL="0" indent="0" algn="l"/>
+            <a:endParaRPr lang="zh-CN" altLang="en-US" sz="1800" b="0" i="0"/>
+          </a:p>
+          <a:p>
+            <a:pPr marL="0" indent="0" algn="l"/>
+            <a:endParaRPr lang="zh-CN" altLang="en-US" sz="1800" b="0" i="0"/>
+          </a:p>
+          <a:p>
+            <a:pPr marL="0" indent="0" algn="l"/>
+            <a:endParaRPr lang="zh-CN" altLang="en-US" sz="1800" b="0" i="0"/>
+          </a:p>
+          <a:p>
+            <a:pPr marL="0" indent="0" algn="l"/>
+            <a:r>
+              <a:rPr lang="zh-CN" altLang="en-US" sz="1800" b="0" i="0"/>
+              <a:t>5.加一个功能区 可以指定哪一个探头对应是哪一个通道，然后可以关闭或者开启哪个探头，关闭的话对应地方的温度就用克里金插值来填充</a:t>
+            </a:r>
+            <a:r>
+              <a:rPr lang="zh-CN" altLang="en-US" sz="1800" b="0" i="0"/>
+              <a:t>就行</a:t>
+            </a:r>
+            <a:endParaRPr lang="zh-CN" altLang="en-US" sz="1800" b="0" i="0"/>
+          </a:p>
+        </p:txBody>
+      </p:sp>
+      <p:sp>
+        <p:nvSpPr>
+          <p:cNvPr id="12" name="圆角矩形 11"/>
+          <p:cNvSpPr/>
+          <p:nvPr/>
+        </p:nvSpPr>
+        <p:spPr>
+          <a:xfrm>
+            <a:off x="2400300" y="2211705"/>
+            <a:ext cx="5989955" cy="1345565"/>
+          </a:xfrm>
+          <a:prstGeom prst="roundRect">
+            <a:avLst/>
+          </a:prstGeom>
+        </p:spPr>
+        <p:style>
+          <a:lnRef idx="2">
+            <a:schemeClr val="accent1"/>
+          </a:lnRef>
+          <a:fillRef idx="0">
+            <a:srgbClr val="FFFFFF"/>
+          </a:fillRef>
+          <a:effectRef idx="0">
+            <a:srgbClr val="FFFFFF"/>
+          </a:effectRef>
+          <a:fontRef idx="minor">
+            <a:schemeClr val="tx1"/>
+          </a:fontRef>
+        </p:style>
+        <p:txBody>
+          <a:bodyPr rtlCol="0" anchor="ctr"/>
+          <a:p>
+            <a:pPr algn="ctr"/>
+            <a:endParaRPr lang="zh-CN" altLang="en-US"/>
+          </a:p>
+        </p:txBody>
+      </p:sp>
+      <p:sp>
+        <p:nvSpPr>
+          <p:cNvPr id="13" name="矩形 12"/>
+          <p:cNvSpPr/>
+          <p:nvPr/>
+        </p:nvSpPr>
+        <p:spPr>
+          <a:xfrm>
+            <a:off x="1690370" y="1849755"/>
+            <a:ext cx="709930" cy="1975485"/>
+          </a:xfrm>
+          <a:prstGeom prst="rect">
+            <a:avLst/>
+          </a:prstGeom>
+        </p:spPr>
+        <p:style>
+          <a:lnRef idx="2">
+            <a:schemeClr val="accent1"/>
+          </a:lnRef>
+          <a:fillRef idx="0">
+            <a:srgbClr val="FFFFFF"/>
+          </a:fillRef>
+          <a:effectRef idx="0">
+            <a:srgbClr val="FFFFFF"/>
+          </a:effectRef>
+          <a:fontRef idx="minor">
+            <a:schemeClr val="tx1"/>
+          </a:fontRef>
+        </p:style>
+        <p:txBody>
+          <a:bodyPr rtlCol="0" anchor="ctr"/>
+          <a:p>
+            <a:pPr algn="ctr"/>
+            <a:endParaRPr lang="zh-CN" altLang="en-US"/>
+          </a:p>
+        </p:txBody>
+      </p:sp>
+      <p:sp>
+        <p:nvSpPr>
+          <p:cNvPr id="14" name="矩形 13"/>
+          <p:cNvSpPr/>
+          <p:nvPr/>
+        </p:nvSpPr>
+        <p:spPr>
+          <a:xfrm>
+            <a:off x="1283335" y="2420620"/>
+            <a:ext cx="407035" cy="937895"/>
+          </a:xfrm>
+          <a:prstGeom prst="rect">
+            <a:avLst/>
+          </a:prstGeom>
+        </p:spPr>
+        <p:style>
+          <a:lnRef idx="2">
+            <a:schemeClr val="accent1"/>
+          </a:lnRef>
+          <a:fillRef idx="0">
+            <a:srgbClr val="FFFFFF"/>
+          </a:fillRef>
+          <a:effectRef idx="0">
+            <a:srgbClr val="FFFFFF"/>
+          </a:effectRef>
+          <a:fontRef idx="minor">
+            <a:schemeClr val="tx1"/>
+          </a:fontRef>
+        </p:style>
+        <p:txBody>
+          <a:bodyPr rtlCol="0" anchor="ctr"/>
+          <a:p>
+            <a:pPr algn="ctr"/>
+            <a:endParaRPr lang="zh-CN" altLang="en-US"/>
+          </a:p>
+        </p:txBody>
+      </p:sp>
+      <p:sp>
+        <p:nvSpPr>
+          <p:cNvPr id="15" name="矩形 14"/>
+          <p:cNvSpPr/>
+          <p:nvPr/>
+        </p:nvSpPr>
+        <p:spPr>
+          <a:xfrm>
+            <a:off x="8389620" y="1849755"/>
+            <a:ext cx="709930" cy="1975485"/>
+          </a:xfrm>
+          <a:prstGeom prst="rect">
+            <a:avLst/>
+          </a:prstGeom>
+        </p:spPr>
+        <p:style>
+          <a:lnRef idx="2">
+            <a:schemeClr val="accent1"/>
+          </a:lnRef>
+          <a:fillRef idx="0">
+            <a:srgbClr val="FFFFFF"/>
+          </a:fillRef>
+          <a:effectRef idx="0">
+            <a:srgbClr val="FFFFFF"/>
+          </a:effectRef>
+          <a:fontRef idx="minor">
+            <a:schemeClr val="tx1"/>
+          </a:fontRef>
+        </p:style>
+        <p:txBody>
+          <a:bodyPr rtlCol="0" anchor="ctr"/>
+          <a:p>
+            <a:pPr algn="ctr"/>
+            <a:endParaRPr lang="zh-CN" altLang="en-US"/>
+          </a:p>
+        </p:txBody>
+      </p:sp>
+      <p:sp>
+        <p:nvSpPr>
+          <p:cNvPr id="17" name="矩形 16"/>
+          <p:cNvSpPr/>
+          <p:nvPr/>
+        </p:nvSpPr>
+        <p:spPr>
+          <a:xfrm>
+            <a:off x="9099550" y="2420620"/>
+            <a:ext cx="407035" cy="937895"/>
+          </a:xfrm>
+          <a:prstGeom prst="rect">
+            <a:avLst/>
+          </a:prstGeom>
+        </p:spPr>
+        <p:style>
+          <a:lnRef idx="2">
+            <a:schemeClr val="accent1"/>
+          </a:lnRef>
+          <a:fillRef idx="0">
+            <a:srgbClr val="FFFFFF"/>
+          </a:fillRef>
+          <a:effectRef idx="0">
+            <a:srgbClr val="FFFFFF"/>
+          </a:effectRef>
+          <a:fontRef idx="minor">
+            <a:schemeClr val="tx1"/>
+          </a:fontRef>
+        </p:style>
+        <p:txBody>
+          <a:bodyPr rtlCol="0" anchor="ctr"/>
+          <a:p>
+            <a:pPr algn="ctr"/>
+            <a:endParaRPr lang="zh-CN" altLang="en-US"/>
+          </a:p>
+        </p:txBody>
+      </p:sp>
+      <p:sp>
+        <p:nvSpPr>
+          <p:cNvPr id="26" name="椭圆 25"/>
+          <p:cNvSpPr/>
+          <p:nvPr/>
+        </p:nvSpPr>
+        <p:spPr>
+          <a:xfrm>
+            <a:off x="2721610" y="2700020"/>
+            <a:ext cx="411480" cy="282575"/>
+          </a:xfrm>
+          <a:prstGeom prst="ellipse">
+            <a:avLst/>
+          </a:prstGeom>
+        </p:spPr>
+        <p:style>
+          <a:lnRef idx="2">
+            <a:schemeClr val="accent1"/>
+          </a:lnRef>
+          <a:fillRef idx="0">
+            <a:srgbClr val="FFFFFF"/>
+          </a:fillRef>
+          <a:effectRef idx="0">
+            <a:srgbClr val="FFFFFF"/>
+          </a:effectRef>
+          <a:fontRef idx="minor">
+            <a:schemeClr val="tx1"/>
+          </a:fontRef>
+        </p:style>
+        <p:txBody>
+          <a:bodyPr rtlCol="0" anchor="ctr"/>
+          <a:p>
+            <a:pPr algn="ctr"/>
+            <a:r>
+              <a:rPr lang="en-US" altLang="zh-CN"/>
+              <a:t>1</a:t>
+            </a:r>
+            <a:endParaRPr lang="en-US" altLang="zh-CN"/>
+          </a:p>
+        </p:txBody>
+      </p:sp>
+      <p:sp>
+        <p:nvSpPr>
+          <p:cNvPr id="27" name="椭圆 26"/>
+          <p:cNvSpPr/>
+          <p:nvPr/>
+        </p:nvSpPr>
+        <p:spPr>
+          <a:xfrm>
+            <a:off x="4391660" y="2700020"/>
+            <a:ext cx="411480" cy="282575"/>
+          </a:xfrm>
+          <a:prstGeom prst="ellipse">
+            <a:avLst/>
+          </a:prstGeom>
+        </p:spPr>
+        <p:style>
+          <a:lnRef idx="2">
+            <a:schemeClr val="accent1"/>
+          </a:lnRef>
+          <a:fillRef idx="0">
+            <a:srgbClr val="FFFFFF"/>
+          </a:fillRef>
+          <a:effectRef idx="0">
+            <a:srgbClr val="FFFFFF"/>
+          </a:effectRef>
+          <a:fontRef idx="minor">
+            <a:schemeClr val="tx1"/>
+          </a:fontRef>
+        </p:style>
+        <p:txBody>
+          <a:bodyPr rtlCol="0" anchor="ctr"/>
+          <a:p>
+            <a:pPr algn="ctr"/>
+            <a:r>
+              <a:rPr lang="en-US" altLang="zh-CN"/>
+              <a:t>3</a:t>
+            </a:r>
+            <a:endParaRPr lang="en-US" altLang="zh-CN"/>
+          </a:p>
+        </p:txBody>
+      </p:sp>
+      <p:sp>
+        <p:nvSpPr>
+          <p:cNvPr id="28" name="椭圆 27"/>
+          <p:cNvSpPr/>
+          <p:nvPr/>
+        </p:nvSpPr>
+        <p:spPr>
+          <a:xfrm>
+            <a:off x="5955030" y="2703195"/>
+            <a:ext cx="411480" cy="282575"/>
+          </a:xfrm>
+          <a:prstGeom prst="ellipse">
+            <a:avLst/>
+          </a:prstGeom>
+        </p:spPr>
+        <p:style>
+          <a:lnRef idx="2">
+            <a:schemeClr val="accent1"/>
+          </a:lnRef>
+          <a:fillRef idx="0">
+            <a:srgbClr val="FFFFFF"/>
+          </a:fillRef>
+          <a:effectRef idx="0">
+            <a:srgbClr val="FFFFFF"/>
+          </a:effectRef>
+          <a:fontRef idx="minor">
+            <a:schemeClr val="tx1"/>
+          </a:fontRef>
+        </p:style>
+        <p:txBody>
+          <a:bodyPr rtlCol="0" anchor="ctr"/>
+          <a:p>
+            <a:pPr algn="ctr"/>
+            <a:r>
+              <a:rPr lang="en-US" altLang="zh-CN"/>
+              <a:t>5</a:t>
+            </a:r>
+            <a:endParaRPr lang="en-US" altLang="zh-CN"/>
+          </a:p>
+        </p:txBody>
+      </p:sp>
+      <p:sp>
+        <p:nvSpPr>
+          <p:cNvPr id="29" name="椭圆 28"/>
+          <p:cNvSpPr/>
+          <p:nvPr/>
+        </p:nvSpPr>
+        <p:spPr>
+          <a:xfrm>
+            <a:off x="7731760" y="2700020"/>
+            <a:ext cx="411480" cy="282575"/>
+          </a:xfrm>
+          <a:prstGeom prst="ellipse">
+            <a:avLst/>
+          </a:prstGeom>
+        </p:spPr>
+        <p:style>
+          <a:lnRef idx="2">
+            <a:schemeClr val="accent1"/>
+          </a:lnRef>
+          <a:fillRef idx="0">
+            <a:srgbClr val="FFFFFF"/>
+          </a:fillRef>
+          <a:effectRef idx="0">
+            <a:srgbClr val="FFFFFF"/>
+          </a:effectRef>
+          <a:fontRef idx="minor">
+            <a:schemeClr val="tx1"/>
+          </a:fontRef>
+        </p:style>
+        <p:txBody>
+          <a:bodyPr rtlCol="0" anchor="ctr"/>
+          <a:p>
+            <a:pPr algn="ctr"/>
+            <a:r>
+              <a:rPr lang="en-US" altLang="zh-CN"/>
+              <a:t>7</a:t>
+            </a:r>
+            <a:endParaRPr lang="en-US" altLang="zh-CN"/>
+          </a:p>
+        </p:txBody>
+      </p:sp>
+      <p:sp>
+        <p:nvSpPr>
+          <p:cNvPr id="30" name="椭圆 29"/>
+          <p:cNvSpPr/>
+          <p:nvPr/>
+        </p:nvSpPr>
+        <p:spPr>
+          <a:xfrm>
+            <a:off x="6884035" y="2703195"/>
+            <a:ext cx="411480" cy="282575"/>
+          </a:xfrm>
+          <a:prstGeom prst="ellipse">
+            <a:avLst/>
+          </a:prstGeom>
+        </p:spPr>
+        <p:style>
+          <a:lnRef idx="2">
+            <a:schemeClr val="accent1"/>
+          </a:lnRef>
+          <a:fillRef idx="0">
+            <a:srgbClr val="FFFFFF"/>
+          </a:fillRef>
+          <a:effectRef idx="0">
+            <a:srgbClr val="FFFFFF"/>
+          </a:effectRef>
+          <a:fontRef idx="minor">
+            <a:schemeClr val="tx1"/>
+          </a:fontRef>
+        </p:style>
+        <p:txBody>
+          <a:bodyPr rtlCol="0" anchor="ctr"/>
+          <a:p>
+            <a:pPr algn="ctr"/>
+            <a:r>
+              <a:rPr lang="en-US" altLang="zh-CN"/>
+              <a:t>6</a:t>
+            </a:r>
+            <a:endParaRPr lang="en-US" altLang="zh-CN"/>
+          </a:p>
+        </p:txBody>
+      </p:sp>
+      <p:sp>
+        <p:nvSpPr>
+          <p:cNvPr id="31" name="椭圆 30"/>
+          <p:cNvSpPr/>
+          <p:nvPr/>
+        </p:nvSpPr>
+        <p:spPr>
+          <a:xfrm>
+            <a:off x="3519805" y="2703195"/>
+            <a:ext cx="411480" cy="282575"/>
+          </a:xfrm>
+          <a:prstGeom prst="ellipse">
+            <a:avLst/>
+          </a:prstGeom>
+        </p:spPr>
+        <p:style>
+          <a:lnRef idx="2">
+            <a:schemeClr val="accent1"/>
+          </a:lnRef>
+          <a:fillRef idx="0">
+            <a:srgbClr val="FFFFFF"/>
+          </a:fillRef>
+          <a:effectRef idx="0">
+            <a:srgbClr val="FFFFFF"/>
+          </a:effectRef>
+          <a:fontRef idx="minor">
+            <a:schemeClr val="tx1"/>
+          </a:fontRef>
+        </p:style>
+        <p:txBody>
+          <a:bodyPr rtlCol="0" anchor="ctr"/>
+          <a:p>
+            <a:pPr algn="ctr"/>
+            <a:r>
+              <a:rPr lang="en-US" altLang="zh-CN"/>
+              <a:t>2</a:t>
+            </a:r>
+            <a:endParaRPr lang="en-US" altLang="zh-CN"/>
+          </a:p>
+        </p:txBody>
+      </p:sp>
+      <p:sp>
+        <p:nvSpPr>
+          <p:cNvPr id="32" name="椭圆 31"/>
+          <p:cNvSpPr/>
+          <p:nvPr/>
+        </p:nvSpPr>
+        <p:spPr>
+          <a:xfrm>
+            <a:off x="5134610" y="2703195"/>
+            <a:ext cx="411480" cy="282575"/>
+          </a:xfrm>
+          <a:prstGeom prst="ellipse">
+            <a:avLst/>
+          </a:prstGeom>
+        </p:spPr>
+        <p:style>
+          <a:lnRef idx="2">
+            <a:schemeClr val="accent1"/>
+          </a:lnRef>
+          <a:fillRef idx="0">
+            <a:srgbClr val="FFFFFF"/>
+          </a:fillRef>
+          <a:effectRef idx="0">
+            <a:srgbClr val="FFFFFF"/>
+          </a:effectRef>
+          <a:fontRef idx="minor">
+            <a:schemeClr val="tx1"/>
+          </a:fontRef>
+        </p:style>
+        <p:txBody>
+          <a:bodyPr rtlCol="0" anchor="ctr"/>
+          <a:p>
+            <a:pPr algn="ctr"/>
+            <a:r>
+              <a:rPr lang="en-US" altLang="zh-CN"/>
+              <a:t>4</a:t>
+            </a:r>
+            <a:endParaRPr lang="en-US" altLang="zh-CN"/>
+          </a:p>
+        </p:txBody>
+      </p:sp>
+      <p:cxnSp>
+        <p:nvCxnSpPr>
+          <p:cNvPr id="7" name="直接连接符 6"/>
+          <p:cNvCxnSpPr/>
+          <p:nvPr/>
+        </p:nvCxnSpPr>
+        <p:spPr>
+          <a:xfrm>
+            <a:off x="944880" y="2842260"/>
+            <a:ext cx="648000" cy="0"/>
+          </a:xfrm>
+          <a:prstGeom prst="line">
+            <a:avLst/>
+          </a:prstGeom>
+          <a:ln w="31750" cap="rnd">
+            <a:solidFill>
+              <a:schemeClr val="accent1"/>
+            </a:solidFill>
+            <a:round/>
+          </a:ln>
+        </p:spPr>
+        <p:style>
+          <a:lnRef idx="0">
+            <a:srgbClr val="FFFFFF"/>
+          </a:lnRef>
+          <a:fillRef idx="0">
+            <a:srgbClr val="FFFFFF"/>
+          </a:fillRef>
+          <a:effectRef idx="0">
+            <a:srgbClr val="FFFFFF"/>
+          </a:effectRef>
+          <a:fontRef idx="minor">
+            <a:schemeClr val="tx1"/>
+          </a:fontRef>
+        </p:style>
+      </p:cxnSp>
+      <p:cxnSp>
+        <p:nvCxnSpPr>
+          <p:cNvPr id="8" name="直接连接符 7"/>
+          <p:cNvCxnSpPr/>
+          <p:nvPr/>
+        </p:nvCxnSpPr>
+        <p:spPr>
+          <a:xfrm>
+            <a:off x="9302750" y="2842260"/>
+            <a:ext cx="648000" cy="0"/>
+          </a:xfrm>
+          <a:prstGeom prst="line">
+            <a:avLst/>
+          </a:prstGeom>
+          <a:ln w="31750" cap="rnd">
+            <a:solidFill>
+              <a:schemeClr val="accent1"/>
+            </a:solidFill>
+            <a:round/>
+          </a:ln>
+        </p:spPr>
+        <p:style>
+          <a:lnRef idx="0">
+            <a:srgbClr val="FFFFFF"/>
+          </a:lnRef>
+          <a:fillRef idx="0">
+            <a:srgbClr val="FFFFFF"/>
+          </a:fillRef>
+          <a:effectRef idx="0">
+            <a:srgbClr val="FFFFFF"/>
+          </a:effectRef>
+          <a:fontRef idx="minor">
+            <a:schemeClr val="tx1"/>
+          </a:fontRef>
+        </p:style>
+      </p:cxnSp>
+      <p:sp>
+        <p:nvSpPr>
+          <p:cNvPr id="9" name="椭圆 8"/>
+          <p:cNvSpPr/>
+          <p:nvPr/>
+        </p:nvSpPr>
+        <p:spPr>
+          <a:xfrm>
+            <a:off x="438785" y="2472055"/>
+            <a:ext cx="622300" cy="313690"/>
+          </a:xfrm>
+          <a:prstGeom prst="ellipse">
+            <a:avLst/>
+          </a:prstGeom>
+        </p:spPr>
+        <p:style>
+          <a:lnRef idx="2">
+            <a:schemeClr val="accent1"/>
+          </a:lnRef>
+          <a:fillRef idx="0">
+            <a:srgbClr val="FFFFFF"/>
+          </a:fillRef>
+          <a:effectRef idx="0">
+            <a:srgbClr val="FFFFFF"/>
+          </a:effectRef>
+          <a:fontRef idx="minor">
+            <a:schemeClr val="tx1"/>
+          </a:fontRef>
+        </p:style>
+        <p:txBody>
+          <a:bodyPr rtlCol="0" anchor="ctr"/>
+          <a:p>
+            <a:pPr algn="ctr"/>
+            <a:r>
+              <a:rPr lang="en-US" altLang="zh-CN"/>
+              <a:t>P1</a:t>
+            </a:r>
+            <a:endParaRPr lang="en-US" altLang="zh-CN"/>
+          </a:p>
+        </p:txBody>
+      </p:sp>
+      <p:sp>
+        <p:nvSpPr>
+          <p:cNvPr id="10" name="椭圆 9"/>
+          <p:cNvSpPr/>
+          <p:nvPr/>
+        </p:nvSpPr>
+        <p:spPr>
+          <a:xfrm>
+            <a:off x="9729470" y="2472055"/>
+            <a:ext cx="622300" cy="313690"/>
+          </a:xfrm>
+          <a:prstGeom prst="ellipse">
+            <a:avLst/>
+          </a:prstGeom>
+        </p:spPr>
+        <p:style>
+          <a:lnRef idx="2">
+            <a:schemeClr val="accent1"/>
+          </a:lnRef>
+          <a:fillRef idx="0">
+            <a:srgbClr val="FFFFFF"/>
+          </a:fillRef>
+          <a:effectRef idx="0">
+            <a:srgbClr val="FFFFFF"/>
+          </a:effectRef>
+          <a:fontRef idx="minor">
+            <a:schemeClr val="tx1"/>
+          </a:fontRef>
+        </p:style>
+        <p:txBody>
+          <a:bodyPr rtlCol="0" anchor="ctr"/>
+          <a:p>
+            <a:pPr algn="ctr"/>
+            <a:r>
+              <a:rPr lang="en-US" altLang="zh-CN"/>
+              <a:t>P2</a:t>
+            </a:r>
+            <a:endParaRPr lang="en-US" altLang="zh-CN"/>
+          </a:p>
+        </p:txBody>
+      </p:sp>
+      <p:pic>
+        <p:nvPicPr>
+          <p:cNvPr id="11" name="图片 10"/>
+          <p:cNvPicPr>
+            <a:picLocks noChangeAspect="1"/>
+          </p:cNvPicPr>
+          <p:nvPr/>
+        </p:nvPicPr>
+        <p:blipFill>
+          <a:blip r:embed="rId1"/>
+          <a:stretch>
+            <a:fillRect/>
+          </a:stretch>
+        </p:blipFill>
+        <p:spPr>
+          <a:xfrm>
+            <a:off x="3830320" y="4792980"/>
+            <a:ext cx="3585210" cy="979170"/>
+          </a:xfrm>
+          <a:prstGeom prst="rect">
+            <a:avLst/>
+          </a:prstGeom>
+        </p:spPr>
+      </p:pic>
     </p:spTree>
   </p:cSld>
   <p:clrMapOvr>

</xml_diff>